<commit_message>
Add QR code to slide 13 in HTML and PPTX presentations
</commit_message>
<xml_diff>
--- a/Civilization_Quest_Presentation.pptx
+++ b/Civilization_Quest_Presentation.pptx
@@ -4409,7 +4409,7 @@
                 <a:ea typeface="Arial" pitchFamily="34" charset="-122"/>
                 <a:cs typeface="Arial" pitchFamily="34" charset="-120"/>
               </a:rPr>
-              <a:t>ФИНАЛЬДЫ КВЕСТ ЖӘНЕ ИНТЕРАКТИВ</a:t>
+              <a:t>QR • ИНТЕРАКТИВТІ КВЕСТ</a:t>
             </a:r>
             <a:endParaRPr lang="en-US" sz="2000" dirty="0"/>
           </a:p>
@@ -4423,180 +4423,18 @@
         </p:nvSpPr>
         <p:spPr>
           <a:xfrm>
-            <a:off x="8961120" y="457200"/>
-            <a:ext cx="2468880" cy="457200"/>
+            <a:off x="3749040" y="1371600"/>
+            <a:ext cx="4663440" cy="4846320"/>
           </a:xfrm>
           <a:prstGeom prst="roundRect">
             <a:avLst>
-              <a:gd name="adj" fmla="val 50000"/>
-            </a:avLst>
-          </a:prstGeom>
-          <a:solidFill>
-            <a:srgbClr val="1E293B"/>
-          </a:solidFill>
-          <a:ln w="12700">
-            <a:solidFill>
-              <a:srgbClr val="F59E0B"/>
-            </a:solidFill>
-            <a:prstDash val="solid"/>
-          </a:ln>
-        </p:spPr>
-      </p:sp>
-      <p:sp>
-        <p:nvSpPr>
-          <p:cNvPr id="4" name="Text 2"/>
-          <p:cNvSpPr/>
-          <p:nvPr/>
-        </p:nvSpPr>
-        <p:spPr>
-          <a:xfrm>
-            <a:off x="8961120" y="457200"/>
-            <a:ext cx="2468880" cy="457200"/>
-          </a:xfrm>
-          <a:prstGeom prst="rect">
-            <a:avLst/>
-          </a:prstGeom>
-          <a:noFill/>
-          <a:ln/>
-        </p:spPr>
-        <p:txBody>
-          <a:bodyPr wrap="square" rtlCol="0" anchor="ctr"/>
-          <a:lstStyle/>
-          <a:p>
-            <a:pPr algn="ctr" indent="0" marL="0">
-              <a:buNone/>
-            </a:pPr>
-            <a:r>
-              <a:rPr lang="en-US" sz="1200" b="1" dirty="0">
-                <a:solidFill>
-                  <a:srgbClr val="F59E0B"/>
-                </a:solidFill>
-              </a:rPr>
-              <a:t>Барлық кілттер жиналды!</a:t>
-            </a:r>
-            <a:endParaRPr lang="en-US" sz="1200" dirty="0"/>
-          </a:p>
-        </p:txBody>
-      </p:sp>
-      <p:sp>
-        <p:nvSpPr>
-          <p:cNvPr id="5" name="Shape 3"/>
-          <p:cNvSpPr/>
-          <p:nvPr/>
-        </p:nvSpPr>
-        <p:spPr>
-          <a:xfrm>
-            <a:off x="731520" y="1371600"/>
-            <a:ext cx="10698480" cy="1005840"/>
-          </a:xfrm>
-          <a:prstGeom prst="roundRect">
-            <a:avLst>
-              <a:gd name="adj" fmla="val 18182"/>
+              <a:gd name="adj" fmla="val 4902"/>
             </a:avLst>
           </a:prstGeom>
           <a:solidFill>
             <a:srgbClr val="0F172A"/>
           </a:solidFill>
-          <a:ln w="12700">
-            <a:solidFill>
-              <a:srgbClr val="334155"/>
-            </a:solidFill>
-            <a:prstDash val="solid"/>
-          </a:ln>
-        </p:spPr>
-      </p:sp>
-      <p:sp>
-        <p:nvSpPr>
-          <p:cNvPr id="6" name="Text 4"/>
-          <p:cNvSpPr/>
-          <p:nvPr/>
-        </p:nvSpPr>
-        <p:spPr>
-          <a:xfrm>
-            <a:off x="914400" y="1463040"/>
-            <a:ext cx="10332720" cy="320040"/>
-          </a:xfrm>
-          <a:prstGeom prst="rect">
-            <a:avLst/>
-          </a:prstGeom>
-          <a:noFill/>
-          <a:ln/>
-        </p:spPr>
-        <p:txBody>
-          <a:bodyPr wrap="square" rtlCol="0" anchor="ctr"/>
-          <a:lstStyle/>
-          <a:p>
-            <a:pPr algn="ctr" indent="0" marL="0">
-              <a:buNone/>
-            </a:pPr>
-            <a:r>
-              <a:rPr lang="en-US" sz="1100" b="1" dirty="0">
-                <a:solidFill>
-                  <a:srgbClr val="94A3B8"/>
-                </a:solidFill>
-              </a:rPr>
-              <a:t>ЖИНАЛҒАН КІЛТ СӨЗДЕР:</a:t>
-            </a:r>
-            <a:endParaRPr lang="en-US" sz="1100" dirty="0"/>
-          </a:p>
-        </p:txBody>
-      </p:sp>
-      <p:sp>
-        <p:nvSpPr>
-          <p:cNvPr id="7" name="Text 5"/>
-          <p:cNvSpPr/>
-          <p:nvPr/>
-        </p:nvSpPr>
-        <p:spPr>
-          <a:xfrm>
-            <a:off x="914400" y="1828800"/>
-            <a:ext cx="10332720" cy="411480"/>
-          </a:xfrm>
-          <a:prstGeom prst="rect">
-            <a:avLst/>
-          </a:prstGeom>
-          <a:noFill/>
-          <a:ln/>
-        </p:spPr>
-        <p:txBody>
-          <a:bodyPr wrap="square" rtlCol="0" anchor="ctr"/>
-          <a:lstStyle/>
-          <a:p>
-            <a:pPr algn="ctr" indent="0" marL="0">
-              <a:buNone/>
-            </a:pPr>
-            <a:r>
-              <a:rPr lang="en-US" sz="1400" b="1" dirty="0">
-                <a:solidFill>
-                  <a:srgbClr val="F59E0B"/>
-                </a:solidFill>
-              </a:rPr>
-              <a:t>Когнитивтік  •  Неолиттік  •  Өркениет  •  Құндылық  •  Отбасы  •  Білім</a:t>
-            </a:r>
-            <a:endParaRPr lang="en-US" sz="1400" dirty="0"/>
-          </a:p>
-        </p:txBody>
-      </p:sp>
-      <p:sp>
-        <p:nvSpPr>
-          <p:cNvPr id="8" name="Shape 6"/>
-          <p:cNvSpPr/>
-          <p:nvPr/>
-        </p:nvSpPr>
-        <p:spPr>
-          <a:xfrm>
-            <a:off x="731520" y="2651760"/>
-            <a:ext cx="5120640" cy="2103120"/>
-          </a:xfrm>
-          <a:prstGeom prst="roundRect">
-            <a:avLst>
-              <a:gd name="adj" fmla="val 8696"/>
-            </a:avLst>
-          </a:prstGeom>
-          <a:solidFill>
-            <a:srgbClr val="0F172A"/>
-          </a:solidFill>
-          <a:ln w="19050">
+          <a:ln w="25400">
             <a:solidFill>
               <a:srgbClr val="38BDF8"/>
             </a:solidFill>
@@ -4606,212 +4444,101 @@
       </p:sp>
       <p:sp>
         <p:nvSpPr>
-          <p:cNvPr id="9" name="Text 7"/>
-          <p:cNvSpPr/>
-          <p:nvPr/>
-        </p:nvSpPr>
-        <p:spPr>
-          <a:xfrm>
-            <a:off x="1005840" y="2926080"/>
-            <a:ext cx="4572000" cy="457200"/>
-          </a:xfrm>
-          <a:prstGeom prst="rect">
-            <a:avLst/>
-          </a:prstGeom>
-          <a:noFill/>
-          <a:ln/>
-        </p:spPr>
-        <p:txBody>
-          <a:bodyPr wrap="square" rtlCol="0" anchor="ctr"/>
-          <a:lstStyle/>
-          <a:p>
-            <a:pPr indent="0" marL="0">
-              <a:buNone/>
-            </a:pPr>
-            <a:r>
-              <a:rPr lang="en-US" sz="1800" b="1" dirty="0">
-                <a:solidFill>
-                  <a:srgbClr val="38BDF8"/>
-                </a:solidFill>
-              </a:rPr>
-              <a:t>1-ОЙЫН: Хронология</a:t>
-            </a:r>
-            <a:endParaRPr lang="en-US" sz="1800" dirty="0"/>
-          </a:p>
-        </p:txBody>
-      </p:sp>
-      <p:sp>
-        <p:nvSpPr>
-          <p:cNvPr id="10" name="Text 8"/>
-          <p:cNvSpPr/>
-          <p:nvPr/>
-        </p:nvSpPr>
-        <p:spPr>
-          <a:xfrm>
-            <a:off x="1005840" y="3474720"/>
-            <a:ext cx="4572000" cy="1005840"/>
-          </a:xfrm>
-          <a:prstGeom prst="rect">
-            <a:avLst/>
-          </a:prstGeom>
-          <a:noFill/>
-          <a:ln/>
-        </p:spPr>
-        <p:txBody>
-          <a:bodyPr wrap="square" rtlCol="0" anchor="ctr"/>
-          <a:lstStyle/>
-          <a:p>
-            <a:pPr indent="0" marL="0">
-              <a:buNone/>
-            </a:pPr>
-            <a:r>
-              <a:rPr lang="en-US" sz="1400" dirty="0">
-                <a:solidFill>
-                  <a:srgbClr val="F8FAFC"/>
-                </a:solidFill>
-              </a:rPr>
-              <a:t>Адамзаттың 6 эволюциялық кезеңін ретімен орналастыру квесті.</a:t>
-            </a:r>
-            <a:endParaRPr lang="en-US" sz="1400" dirty="0"/>
-          </a:p>
-        </p:txBody>
-      </p:sp>
-      <p:sp>
-        <p:nvSpPr>
-          <p:cNvPr id="11" name="Shape 9"/>
-          <p:cNvSpPr/>
-          <p:nvPr/>
-        </p:nvSpPr>
-        <p:spPr>
-          <a:xfrm>
-            <a:off x="6309360" y="2651760"/>
-            <a:ext cx="5120640" cy="2103120"/>
+          <p:cNvPr id="4" name="Shape 2"/>
+          <p:cNvSpPr/>
+          <p:nvPr/>
+        </p:nvSpPr>
+        <p:spPr>
+          <a:xfrm>
+            <a:off x="4389120" y="1645920"/>
+            <a:ext cx="3383280" cy="3383280"/>
           </a:xfrm>
           <a:prstGeom prst="roundRect">
             <a:avLst>
-              <a:gd name="adj" fmla="val 8696"/>
+              <a:gd name="adj" fmla="val 4054"/>
             </a:avLst>
           </a:prstGeom>
           <a:solidFill>
-            <a:srgbClr val="0F172A"/>
+            <a:srgbClr val="FFFFFF"/>
           </a:solidFill>
-          <a:ln w="19050">
+          <a:ln w="12700">
             <a:solidFill>
-              <a:srgbClr val="F59E0B"/>
+              <a:srgbClr val="E2E8F0"/>
             </a:solidFill>
             <a:prstDash val="solid"/>
           </a:ln>
         </p:spPr>
       </p:sp>
-      <p:sp>
-        <p:nvSpPr>
-          <p:cNvPr id="12" name="Text 10"/>
-          <p:cNvSpPr/>
-          <p:nvPr/>
-        </p:nvSpPr>
-        <p:spPr>
-          <a:xfrm>
-            <a:off x="6583680" y="2926080"/>
-            <a:ext cx="4572000" cy="457200"/>
-          </a:xfrm>
-          <a:prstGeom prst="rect">
-            <a:avLst/>
-          </a:prstGeom>
-          <a:noFill/>
-          <a:ln/>
-        </p:spPr>
-        <p:txBody>
-          <a:bodyPr wrap="square" rtlCol="0" anchor="ctr"/>
-          <a:lstStyle/>
-          <a:p>
-            <a:pPr indent="0" marL="0">
-              <a:buNone/>
-            </a:pPr>
-            <a:r>
-              <a:rPr lang="en-US" sz="1800" b="1" dirty="0">
-                <a:solidFill>
-                  <a:srgbClr val="F59E0B"/>
-                </a:solidFill>
-              </a:rPr>
-              <a:t>2-ОЙЫН: Модель құрау</a:t>
-            </a:r>
-            <a:endParaRPr lang="en-US" sz="1800" dirty="0"/>
-          </a:p>
-        </p:txBody>
-      </p:sp>
-      <p:sp>
-        <p:nvSpPr>
-          <p:cNvPr id="13" name="Text 11"/>
-          <p:cNvSpPr/>
-          <p:nvPr/>
-        </p:nvSpPr>
-        <p:spPr>
-          <a:xfrm>
-            <a:off x="6583680" y="3474720"/>
-            <a:ext cx="4572000" cy="1005840"/>
-          </a:xfrm>
-          <a:prstGeom prst="rect">
-            <a:avLst/>
-          </a:prstGeom>
-          <a:noFill/>
-          <a:ln/>
-        </p:spPr>
-        <p:txBody>
-          <a:bodyPr wrap="square" rtlCol="0" anchor="ctr"/>
-          <a:lstStyle/>
-          <a:p>
-            <a:pPr indent="0" marL="0">
-              <a:buNone/>
-            </a:pPr>
-            <a:r>
-              <a:rPr lang="en-US" sz="1400" dirty="0">
+      <p:pic>
+        <p:nvPicPr>
+          <p:cNvPr id="5" name="Image 0" descr="qr.png">    </p:cNvPr>
+          <p:cNvPicPr>
+            <a:picLocks noChangeAspect="1"/>
+          </p:cNvPicPr>
+          <p:nvPr/>
+        </p:nvPicPr>
+        <p:blipFill>
+          <a:blip r:embed="rId1"/>
+          <a:stretch>
+            <a:fillRect/>
+          </a:stretch>
+        </p:blipFill>
+        <p:spPr>
+          <a:xfrm>
+            <a:off x="4526280" y="1783080"/>
+            <a:ext cx="3108960" cy="3108960"/>
+          </a:xfrm>
+          <a:prstGeom prst="rect">
+            <a:avLst/>
+          </a:prstGeom>
+        </p:spPr>
+      </p:pic>
+      <p:sp>
+        <p:nvSpPr>
+          <p:cNvPr id="6" name="Text 3"/>
+          <p:cNvSpPr/>
+          <p:nvPr/>
+        </p:nvSpPr>
+        <p:spPr>
+          <a:xfrm>
+            <a:off x="3840480" y="5212080"/>
+            <a:ext cx="4480560" cy="411480"/>
+          </a:xfrm>
+          <a:prstGeom prst="rect">
+            <a:avLst/>
+          </a:prstGeom>
+          <a:noFill/>
+          <a:ln/>
+        </p:spPr>
+        <p:txBody>
+          <a:bodyPr wrap="square" rtlCol="0" anchor="ctr"/>
+          <a:lstStyle/>
+          <a:p>
+            <a:pPr algn="ctr" indent="0" marL="0">
+              <a:buNone/>
+            </a:pPr>
+            <a:r>
+              <a:rPr lang="en-US" sz="1600" b="1" dirty="0">
                 <a:solidFill>
                   <a:srgbClr val="F8FAFC"/>
                 </a:solidFill>
               </a:rPr>
-              <a:t>Тұлғаны қалыптастырушы факторлар мен құндылықтарды таңдау квесті.</a:t>
-            </a:r>
-            <a:endParaRPr lang="en-US" sz="1400" dirty="0"/>
-          </a:p>
-        </p:txBody>
-      </p:sp>
-      <p:sp>
-        <p:nvSpPr>
-          <p:cNvPr id="14" name="Shape 12"/>
-          <p:cNvSpPr/>
-          <p:nvPr/>
-        </p:nvSpPr>
-        <p:spPr>
-          <a:xfrm>
-            <a:off x="731520" y="5029200"/>
-            <a:ext cx="10698480" cy="1188720"/>
-          </a:xfrm>
-          <a:prstGeom prst="roundRect">
-            <a:avLst>
-              <a:gd name="adj" fmla="val 15385"/>
-            </a:avLst>
-          </a:prstGeom>
-          <a:solidFill>
-            <a:srgbClr val="1E293B"/>
-          </a:solidFill>
-          <a:ln w="25400">
-            <a:solidFill>
-              <a:srgbClr val="F59E0B"/>
-            </a:solidFill>
-            <a:prstDash val="solid"/>
-          </a:ln>
-        </p:spPr>
-      </p:sp>
-      <p:sp>
-        <p:nvSpPr>
-          <p:cNvPr id="15" name="Text 13"/>
-          <p:cNvSpPr/>
-          <p:nvPr/>
-        </p:nvSpPr>
-        <p:spPr>
-          <a:xfrm>
-            <a:off x="914400" y="5029200"/>
-            <a:ext cx="10332720" cy="1188720"/>
+              <a:t>Камераны бағыттап, квест-ойынға өтіңіз</a:t>
+            </a:r>
+            <a:endParaRPr lang="en-US" sz="1600" dirty="0"/>
+          </a:p>
+        </p:txBody>
+      </p:sp>
+      <p:sp>
+        <p:nvSpPr>
+          <p:cNvPr id="7" name="Text 4"/>
+          <p:cNvSpPr/>
+          <p:nvPr/>
+        </p:nvSpPr>
+        <p:spPr>
+          <a:xfrm>
+            <a:off x="3840480" y="5623560"/>
+            <a:ext cx="4480560" cy="365760"/>
           </a:xfrm>
           <a:prstGeom prst="rect">
             <a:avLst/>
@@ -4827,28 +4554,14 @@
               <a:buNone/>
             </a:pPr>
             <a:r>
-              <a:rPr lang="en-US" sz="2000" b="1" dirty="0">
-                <a:solidFill>
-                  <a:srgbClr val="F8FAFC"/>
-                </a:solidFill>
-              </a:rPr>
-              <a:t>«ӨРКЕНИЕТ ҚОҒАМДЫ ӨЗГЕРТЕДІ.</a:t>
-            </a:r>
-            <a:endParaRPr lang="en-US" sz="2000" dirty="0"/>
-          </a:p>
-          <a:p>
-            <a:pPr algn="ctr" indent="0" marL="0">
-              <a:buNone/>
-            </a:pPr>
-            <a:r>
-              <a:rPr lang="en-US" sz="2000" b="1" dirty="0">
-                <a:solidFill>
-                  <a:srgbClr val="F8FAFC"/>
-                </a:solidFill>
-              </a:rPr>
-              <a:t>ҚҰНДЫЛЫҚ АДАМДЫ ҚАЛЫПТАСТЫРАДЫ.»</a:t>
-            </a:r>
-            <a:endParaRPr lang="en-US" sz="2000" dirty="0"/>
+              <a:rPr lang="en-US" sz="1200" dirty="0">
+                <a:solidFill>
+                  <a:srgbClr val="94A3B8"/>
+                </a:solidFill>
+              </a:rPr>
+              <a:t>Интерактивті веб-платформа &amp; хронология ойыны</a:t>
+            </a:r>
+            <a:endParaRPr lang="en-US" sz="1200" dirty="0"/>
           </a:p>
         </p:txBody>
       </p:sp>

</xml_diff>